<commit_message>
Update all PPTs to Times New Roman and add dedicated details slide
</commit_message>
<xml_diff>
--- a/WEEK_1_Day_3_Mentor_Review.pptx
+++ b/WEEK_1_Day_3_Mentor_Review.pptx
@@ -8,6 +8,7 @@
     <p:sldId id="256" r:id="rId3"/>
     <p:sldId id="257" r:id="rId4"/>
     <p:sldId id="258" r:id="rId5"/>
+    <p:sldId id="259" r:id="rId9"/>
   </p:sldIdLst>
   <p:sldSz cx="9144000" cy="6858000" type="screen4x3"/>
   <p:notesSz cx="6858000" cy="9144000"/>
@@ -3093,7 +3094,7 @@
             </a:br>
             <a:r>
               <a:rPr>
-                <a:latin typeface="Algerian" panose="04020705040A02060702" charset="0"/>
+                <a:latin typeface="Times New Roman" panose="04020705040A02060702" charset="0"/>
                 <a:cs typeface="Algerian" panose="04020705040A02060702" charset="0"/>
               </a:rPr>
               <a:t>1. Revised Research Framing &amp; Targets</a:t>
@@ -3352,7 +3353,7 @@
           <a:p>
             <a:r>
               <a:rPr>
-                <a:latin typeface="Algerian" panose="04020705040A02060702" charset="0"/>
+                <a:latin typeface="Times New Roman" panose="04020705040A02060702" charset="0"/>
                 <a:cs typeface="Algerian" panose="04020705040A02060702" charset="0"/>
               </a:rPr>
               <a:t>2. Progress Update: Completed Work &amp; Findings</a:t>
@@ -3534,7 +3535,7 @@
           <a:p>
             <a:r>
               <a:rPr>
-                <a:latin typeface="Algerian" panose="04020705040A02060702" charset="0"/>
+                <a:latin typeface="Times New Roman" panose="04020705040A02060702" charset="0"/>
                 <a:cs typeface="Algerian" panose="04020705040A02060702" charset="0"/>
               </a:rPr>
               <a:t>3. Blockers &amp; Next 3-Day Plan</a:t>
@@ -3676,6 +3677,104 @@
               <a:latin typeface="Times New Roman" panose="02020603050405020304" charset="0"/>
               <a:cs typeface="Times New Roman" panose="02020603050405020304" charset="0"/>
             </a:endParaRPr>
+          </a:p>
+        </p:txBody>
+      </p:sp>
+    </p:spTree>
+  </p:cSld>
+  <p:clrMapOvr>
+    <a:masterClrMapping/>
+  </p:clrMapOvr>
+</p:sld>
+</file>
+
+<file path=ppt/slides/slide4.xml><?xml version="1.0" encoding="utf-8"?>
+<p:sld xmlns:a="http://schemas.openxmlformats.org/drawingml/2006/main" xmlns:p="http://schemas.openxmlformats.org/presentationml/2006/main" xmlns:r="http://schemas.openxmlformats.org/officeDocument/2006/relationships">
+  <p:cSld>
+    <p:spTree>
+      <p:nvGrpSpPr>
+        <p:cNvPr id="1" name=""/>
+        <p:cNvGrpSpPr/>
+        <p:nvPr/>
+      </p:nvGrpSpPr>
+      <p:grpSpPr/>
+      <p:sp>
+        <p:nvSpPr>
+          <p:cNvPr id="2" name="Title 1"/>
+          <p:cNvSpPr>
+            <a:spLocks noGrp="1"/>
+          </p:cNvSpPr>
+          <p:nvPr>
+            <p:ph type="title"/>
+          </p:nvPr>
+        </p:nvSpPr>
+        <p:spPr/>
+        <p:txBody>
+          <a:bodyPr/>
+          <a:lstStyle/>
+          <a:p>
+            <a:r>
+              <a:rPr>
+                <a:latin typeface="Times New Roman"/>
+              </a:rPr>
+              <a:t>Project Details</a:t>
+            </a:r>
+          </a:p>
+        </p:txBody>
+      </p:sp>
+      <p:sp>
+        <p:nvSpPr>
+          <p:cNvPr id="3" name="Content Placeholder 2"/>
+          <p:cNvSpPr>
+            <a:spLocks noGrp="1"/>
+          </p:cNvSpPr>
+          <p:nvPr>
+            <p:ph idx="1"/>
+          </p:nvPr>
+        </p:nvSpPr>
+        <p:spPr/>
+        <p:txBody>
+          <a:bodyPr/>
+          <a:lstStyle/>
+          <a:p/>
+          <a:p>
+            <a:pPr>
+              <a:spcAft>
+                <a:spcPts val="1400"/>
+              </a:spcAft>
+            </a:pPr>
+            <a:r>
+              <a:rPr sz="2800">
+                <a:latin typeface="Times New Roman"/>
+              </a:rPr>
+              <a:t>Name: K.Santhosh Reddy</a:t>
+            </a:r>
+          </a:p>
+          <a:p>
+            <a:pPr>
+              <a:spcAft>
+                <a:spcPts val="1400"/>
+              </a:spcAft>
+            </a:pPr>
+            <a:r>
+              <a:rPr sz="2800">
+                <a:latin typeface="Times New Roman"/>
+              </a:rPr>
+              <a:t>Cohort: 4 Batch A2</a:t>
+            </a:r>
+          </a:p>
+          <a:p>
+            <a:pPr>
+              <a:spcAft>
+                <a:spcPts val="1400"/>
+              </a:spcAft>
+            </a:pPr>
+            <a:r>
+              <a:rPr sz="2800">
+                <a:latin typeface="Times New Roman"/>
+              </a:rPr>
+              <a:t>Mentor: Mr. Vamshi</a:t>
+            </a:r>
           </a:p>
         </p:txBody>
       </p:sp>

</xml_diff>

<commit_message>
Format PPT presentations and add project details
</commit_message>
<xml_diff>
--- a/WEEK_1_Day_3_Mentor_Review.pptx
+++ b/WEEK_1_Day_3_Mentor_Review.pptx
@@ -8,6 +8,7 @@
     <p:sldId id="256" r:id="rId3"/>
     <p:sldId id="257" r:id="rId4"/>
     <p:sldId id="258" r:id="rId5"/>
+    <p:sldId id="259" r:id="rId9"/>
   </p:sldIdLst>
   <p:sldSz cx="9144000" cy="6858000" type="screen4x3"/>
   <p:notesSz cx="6858000" cy="9144000"/>
@@ -3093,7 +3094,7 @@
             </a:br>
             <a:r>
               <a:rPr>
-                <a:latin typeface="Algerian" panose="04020705040A02060702" charset="0"/>
+                <a:latin typeface="Times New Roman" panose="04020705040A02060702" charset="0"/>
                 <a:cs typeface="Algerian" panose="04020705040A02060702" charset="0"/>
               </a:rPr>
               <a:t>1. Revised Research Framing &amp; Targets</a:t>
@@ -3352,7 +3353,7 @@
           <a:p>
             <a:r>
               <a:rPr>
-                <a:latin typeface="Algerian" panose="04020705040A02060702" charset="0"/>
+                <a:latin typeface="Times New Roman" panose="04020705040A02060702" charset="0"/>
                 <a:cs typeface="Algerian" panose="04020705040A02060702" charset="0"/>
               </a:rPr>
               <a:t>2. Progress Update: Completed Work &amp; Findings</a:t>
@@ -3534,7 +3535,7 @@
           <a:p>
             <a:r>
               <a:rPr>
-                <a:latin typeface="Algerian" panose="04020705040A02060702" charset="0"/>
+                <a:latin typeface="Times New Roman" panose="04020705040A02060702" charset="0"/>
                 <a:cs typeface="Algerian" panose="04020705040A02060702" charset="0"/>
               </a:rPr>
               <a:t>3. Blockers &amp; Next 3-Day Plan</a:t>
@@ -3676,6 +3677,104 @@
               <a:latin typeface="Times New Roman" panose="02020603050405020304" charset="0"/>
               <a:cs typeface="Times New Roman" panose="02020603050405020304" charset="0"/>
             </a:endParaRPr>
+          </a:p>
+        </p:txBody>
+      </p:sp>
+    </p:spTree>
+  </p:cSld>
+  <p:clrMapOvr>
+    <a:masterClrMapping/>
+  </p:clrMapOvr>
+</p:sld>
+</file>
+
+<file path=ppt/slides/slide4.xml><?xml version="1.0" encoding="utf-8"?>
+<p:sld xmlns:a="http://schemas.openxmlformats.org/drawingml/2006/main" xmlns:p="http://schemas.openxmlformats.org/presentationml/2006/main" xmlns:r="http://schemas.openxmlformats.org/officeDocument/2006/relationships">
+  <p:cSld>
+    <p:spTree>
+      <p:nvGrpSpPr>
+        <p:cNvPr id="1" name=""/>
+        <p:cNvGrpSpPr/>
+        <p:nvPr/>
+      </p:nvGrpSpPr>
+      <p:grpSpPr/>
+      <p:sp>
+        <p:nvSpPr>
+          <p:cNvPr id="2" name="Title 1"/>
+          <p:cNvSpPr>
+            <a:spLocks noGrp="1"/>
+          </p:cNvSpPr>
+          <p:nvPr>
+            <p:ph type="title"/>
+          </p:nvPr>
+        </p:nvSpPr>
+        <p:spPr/>
+        <p:txBody>
+          <a:bodyPr/>
+          <a:lstStyle/>
+          <a:p>
+            <a:r>
+              <a:rPr>
+                <a:latin typeface="Times New Roman"/>
+              </a:rPr>
+              <a:t>Project Details</a:t>
+            </a:r>
+          </a:p>
+        </p:txBody>
+      </p:sp>
+      <p:sp>
+        <p:nvSpPr>
+          <p:cNvPr id="3" name="Content Placeholder 2"/>
+          <p:cNvSpPr>
+            <a:spLocks noGrp="1"/>
+          </p:cNvSpPr>
+          <p:nvPr>
+            <p:ph idx="1"/>
+          </p:nvPr>
+        </p:nvSpPr>
+        <p:spPr/>
+        <p:txBody>
+          <a:bodyPr/>
+          <a:lstStyle/>
+          <a:p/>
+          <a:p>
+            <a:pPr>
+              <a:spcAft>
+                <a:spcPts val="1400"/>
+              </a:spcAft>
+            </a:pPr>
+            <a:r>
+              <a:rPr sz="2800">
+                <a:latin typeface="Times New Roman"/>
+              </a:rPr>
+              <a:t>Name: K.Santhosh Reddy</a:t>
+            </a:r>
+          </a:p>
+          <a:p>
+            <a:pPr>
+              <a:spcAft>
+                <a:spcPts val="1400"/>
+              </a:spcAft>
+            </a:pPr>
+            <a:r>
+              <a:rPr sz="2800">
+                <a:latin typeface="Times New Roman"/>
+              </a:rPr>
+              <a:t>Cohort: 4 Batch A2</a:t>
+            </a:r>
+          </a:p>
+          <a:p>
+            <a:pPr>
+              <a:spcAft>
+                <a:spcPts val="1400"/>
+              </a:spcAft>
+            </a:pPr>
+            <a:r>
+              <a:rPr sz="2800">
+                <a:latin typeface="Times New Roman"/>
+              </a:rPr>
+              <a:t>Mentor: Mr. Vamshi</a:t>
+            </a:r>
           </a:p>
         </p:txBody>
       </p:sp>

</xml_diff>